<commit_message>
Rebuild presentation with current results
</commit_message>
<xml_diff>
--- a/docs/presentation/vulp_v1.pptx
+++ b/docs/presentation/vulp_v1.pptx
@@ -588,7 +588,7 @@
           <a:lstStyle/>
           <a:p>
             <a:r>
-              <a:t>Four of six problems are within 10% of C++. The two gaps are understood: the element width in the LCS table, and the map implementation.</a:t>
+              <a:t>Map allocations and LCS table representation account for the largest gaps in these runs.</a:t>
             </a:r>
           </a:p>
         </p:txBody>
@@ -728,7 +728,7 @@
           <a:lstStyle/>
           <a:p>
             <a:r>
-              <a:t>About 14× faster builds than g++, mostly because g++ parses all of bits/stdc++.h. The JIT adds only tens of milliseconds, so edit-run cycles are instant.</a:t>
+              <a:t>Vulp builds take 0.05-0.06 s and the C++ builds take 0.96-1.05 s. The C++ sources include bits/stdc++.h. JIT startup adds roughly 16-35 ms to execution.</a:t>
             </a:r>
           </a:p>
         </p:txBody>
@@ -798,7 +798,7 @@
           <a:lstStyle/>
           <a:p>
             <a:r>
-              <a:t>This is the honest weak spot. A memoised recursion can't beat a table, but the memo table itself should reach parity with C++ unordered_map; the fixes are inside the runtime.</a:t>
+              <a:t>On this dense problem, a table avoids hash lookups and stores each value in a compact array. The Fibonacci comparison shows the benefit of caching when plain recursion repeats work.</a:t>
             </a:r>
           </a:p>
         </p:txBody>
@@ -868,7 +868,7 @@
           <a:lstStyle/>
           <a:p>
             <a:r>
-              <a:t>Bounds checks stay on by default because they are nearly free. Picking the element width is the bigger lever, and Vulp makes it a one-word change.</a:t>
+              <a:t>The measured i32 table uses 38.1 MiB and takes 0.033 s; the 64-bit table uses 72.6 MiB and takes 0.048 s.</a:t>
             </a:r>
           </a:p>
         </p:txBody>
@@ -1358,7 +1358,7 @@
           <a:lstStyle/>
           <a:p>
             <a:r>
-              <a:t>dp turns a naive recursion into a memoised one. The compiler proves the function is safe to cache and decides whether the cache must be reset between testcases.</a:t>
+              <a:t>For fib(40), dp fn takes 0.00157 s, close to process startup. The compiler checks the function's cache rules and resets input-dependent caches between testcases.</a:t>
             </a:r>
           </a:p>
         </p:txBody>
@@ -1638,7 +1638,7 @@
           <a:lstStyle/>
           <a:p>
             <a:r>
-              <a:t>Each problem has a Vulp, C++ and Python version. The harness checks that all of them print the same bytes before any time is recorded. Runs are interleaved because the machine is shared.</a:t>
+              <a:t>Each problem has a Vulp, C++ and Python version. The harness checks that all of them print the same bytes before timing. Runs are interleaved and pinned to one CPU on the reference laptop.</a:t>
             </a:r>
           </a:p>
         </p:txBody>
@@ -5340,7 +5340,7 @@
                 </a:solidFill>
                 <a:latin typeface="Calibri"/>
               </a:rPr>
-              <a:t>Runtime: C++ speed, 4.5–14× faster than Python</a:t>
+              <a:t>Runtime: Vulp vs C++ and Python</a:t>
             </a:r>
           </a:p>
         </p:txBody>
@@ -5406,7 +5406,7 @@
                 </a:solidFill>
                 <a:latin typeface="Calibri"/>
               </a:rPr>
-              <a:t>•  Equal to C++ on sieve, Dijkstra and testcases</a:t>
+              <a:t>•  Within 17% of C++ on four tasks</a:t>
             </a:r>
           </a:p>
           <a:p>
@@ -5425,7 +5425,7 @@
                 </a:solidFill>
                 <a:latin typeface="Calibri"/>
               </a:rPr>
-              <a:t>•  10% faster on sort + I/O: Vulp's reader and printer beat untied iostreams</a:t>
+              <a:t>•  Vulp is 4.6x to 19.5x faster than Python on five tasks</a:t>
             </a:r>
           </a:p>
           <a:p>
@@ -5444,7 +5444,7 @@
                 </a:solidFill>
                 <a:latin typeface="Calibri"/>
               </a:rPr>
-              <a:t>•  LCS table 1.88×: int (64-bit) vs C++'s 32-bit int; with i32 it is 1.13×</a:t>
+              <a:t>•  LCS: i32 tables, 1.37x C++ time; about 38 MiB each</a:t>
             </a:r>
           </a:p>
           <a:p>
@@ -5463,7 +5463,7 @@
                 </a:solidFill>
                 <a:latin typeface="Calibri"/>
               </a:rPr>
-              <a:t>•  Map 1.46×: values in separate allocations, calls into the runtime</a:t>
+              <a:t>•  Map counting is 1.42x C++ time and nearly equal to Python</a:t>
             </a:r>
           </a:p>
         </p:txBody>
@@ -6023,7 +6023,7 @@
                 </a:solidFill>
                 <a:latin typeface="Calibri"/>
               </a:rPr>
-              <a:t>Build in 0.1 s, or run straight from source</a:t>
+              <a:t>Build in 0.05 s, or run straight from source</a:t>
             </a:r>
           </a:p>
         </p:txBody>
@@ -6181,7 +6181,7 @@
                 </a:solidFill>
                 <a:latin typeface="Calibri"/>
               </a:rPr>
-              <a:t>0.09–0.13 s</a:t>
+              <a:t>0.05–0.06 s</a:t>
             </a:r>
           </a:p>
         </p:txBody>
@@ -6357,7 +6357,7 @@
                 </a:solidFill>
                 <a:latin typeface="Calibri"/>
               </a:rPr>
-              <a:t>1.38–1.49 s</a:t>
+              <a:t>0.96–1.05 s</a:t>
             </a:r>
           </a:p>
         </p:txBody>
@@ -6533,7 +6533,7 @@
                 </a:solidFill>
                 <a:latin typeface="Calibri"/>
               </a:rPr>
-              <a:t>+20–45 ms</a:t>
+              <a:t>+16-35 ms</a:t>
             </a:r>
           </a:p>
         </p:txBody>
@@ -6719,35 +6719,393 @@
                 </a:solidFill>
                 <a:latin typeface="Calibri"/>
               </a:rPr>
-              <a:t>The price of dp fn</a:t>
-            </a:r>
-          </a:p>
-        </p:txBody>
-      </p:sp>
-      <p:pic>
-        <p:nvPicPr>
-          <p:cNvPr id="4" name="Picture 3" descr="lcs_variants.png"/>
-          <p:cNvPicPr>
-            <a:picLocks noChangeAspect="1"/>
-          </p:cNvPicPr>
-          <p:nvPr/>
-        </p:nvPicPr>
-        <p:blipFill>
-          <a:blip r:embed="rId2"/>
-          <a:stretch>
-            <a:fillRect/>
-          </a:stretch>
-        </p:blipFill>
-        <p:spPr>
-          <a:xfrm>
-            <a:off x="457200" y="1325880"/>
-            <a:ext cx="7498079" cy="3019043"/>
-          </a:xfrm>
-          <a:prstGeom prst="rect">
-            <a:avLst/>
-          </a:prstGeom>
-        </p:spPr>
-      </p:pic>
+              <a:t>Memoization and dense tables</a:t>
+            </a:r>
+          </a:p>
+        </p:txBody>
+      </p:sp>
+      <p:graphicFrame>
+        <p:nvGraphicFramePr>
+          <p:cNvPr id="4" name="Table 3"/>
+          <p:cNvGraphicFramePr>
+            <a:graphicFrameLocks noGrp="1"/>
+          </p:cNvGraphicFramePr>
+          <p:nvPr/>
+        </p:nvGraphicFramePr>
+        <p:xfrm>
+          <a:off x="365760" y="1508760"/>
+          <a:ext cx="7589520" cy="2834640"/>
+        </p:xfrm>
+        <a:graphic>
+          <a:graphicData uri="http://schemas.openxmlformats.org/drawingml/2006/table">
+            <a:tbl>
+              <a:tblPr firstRow="1">
+                <a:tableStyleId>{5C22544A-7EE6-4342-B048-85BDC9FD1C3A}</a:tableStyleId>
+              </a:tblPr>
+              <a:tblGrid>
+                <a:gridCol w="3840480"/>
+                <a:gridCol w="1371600"/>
+                <a:gridCol w="2377440"/>
+              </a:tblGrid>
+              <a:tr h="566928">
+                <a:tc>
+                  <a:txBody>
+                    <a:bodyPr wrap="square"/>
+                    <a:lstStyle/>
+                    <a:p>
+                      <a:pPr algn="l"/>
+                      <a:r>
+                        <a:rPr sz="1400" b="1">
+                          <a:solidFill>
+                            <a:srgbClr val="0B0B0B"/>
+                          </a:solidFill>
+                          <a:latin typeface="Calibri"/>
+                        </a:rPr>
+                        <a:t>Implementation</a:t>
+                      </a:r>
+                    </a:p>
+                  </a:txBody>
+                  <a:tcPr marL="73152" marR="73152" marT="27432" marB="27432" anchor="ctr">
+                    <a:solidFill>
+                      <a:srgbClr val="EAF2FC"/>
+                    </a:solidFill>
+                  </a:tcPr>
+                </a:tc>
+                <a:tc>
+                  <a:txBody>
+                    <a:bodyPr wrap="square"/>
+                    <a:lstStyle/>
+                    <a:p>
+                      <a:pPr algn="r"/>
+                      <a:r>
+                        <a:rPr sz="1400" b="1">
+                          <a:solidFill>
+                            <a:srgbClr val="0B0B0B"/>
+                          </a:solidFill>
+                          <a:latin typeface="Calibri"/>
+                        </a:rPr>
+                        <a:t>Time (s)</a:t>
+                      </a:r>
+                    </a:p>
+                  </a:txBody>
+                  <a:tcPr marL="73152" marR="73152" marT="27432" marB="27432" anchor="ctr">
+                    <a:solidFill>
+                      <a:srgbClr val="EAF2FC"/>
+                    </a:solidFill>
+                  </a:tcPr>
+                </a:tc>
+                <a:tc>
+                  <a:txBody>
+                    <a:bodyPr wrap="square"/>
+                    <a:lstStyle/>
+                    <a:p>
+                      <a:pPr algn="r"/>
+                      <a:r>
+                        <a:rPr sz="1400" b="1">
+                          <a:solidFill>
+                            <a:srgbClr val="0B0B0B"/>
+                          </a:solidFill>
+                          <a:latin typeface="Calibri"/>
+                        </a:rPr>
+                        <a:t>Peak memory (MiB)</a:t>
+                      </a:r>
+                    </a:p>
+                  </a:txBody>
+                  <a:tcPr marL="73152" marR="73152" marT="27432" marB="27432" anchor="ctr">
+                    <a:solidFill>
+                      <a:srgbClr val="EAF2FC"/>
+                    </a:solidFill>
+                  </a:tcPr>
+                </a:tc>
+              </a:tr>
+              <a:tr h="566928">
+                <a:tc>
+                  <a:txBody>
+                    <a:bodyPr wrap="square"/>
+                    <a:lstStyle/>
+                    <a:p>
+                      <a:pPr algn="l"/>
+                      <a:r>
+                        <a:rPr sz="1400" b="0">
+                          <a:solidFill>
+                            <a:srgbClr val="0B0B0B"/>
+                          </a:solidFill>
+                          <a:latin typeface="Calibri"/>
+                        </a:rPr>
+                        <a:t>Vulp dp fn</a:t>
+                      </a:r>
+                    </a:p>
+                  </a:txBody>
+                  <a:tcPr marL="73152" marR="73152" marT="27432" marB="27432" anchor="ctr">
+                    <a:solidFill>
+                      <a:srgbClr val="FCFCFB"/>
+                    </a:solidFill>
+                  </a:tcPr>
+                </a:tc>
+                <a:tc>
+                  <a:txBody>
+                    <a:bodyPr wrap="square"/>
+                    <a:lstStyle/>
+                    <a:p>
+                      <a:pPr algn="r"/>
+                      <a:r>
+                        <a:rPr sz="1400" b="0">
+                          <a:solidFill>
+                            <a:srgbClr val="0B0B0B"/>
+                          </a:solidFill>
+                          <a:latin typeface="Calibri"/>
+                        </a:rPr>
+                        <a:t>1.581</a:t>
+                      </a:r>
+                    </a:p>
+                  </a:txBody>
+                  <a:tcPr marL="73152" marR="73152" marT="27432" marB="27432" anchor="ctr">
+                    <a:solidFill>
+                      <a:srgbClr val="FCFCFB"/>
+                    </a:solidFill>
+                  </a:tcPr>
+                </a:tc>
+                <a:tc>
+                  <a:txBody>
+                    <a:bodyPr wrap="square"/>
+                    <a:lstStyle/>
+                    <a:p>
+                      <a:pPr algn="r"/>
+                      <a:r>
+                        <a:rPr sz="1400" b="0">
+                          <a:solidFill>
+                            <a:srgbClr val="0B0B0B"/>
+                          </a:solidFill>
+                          <a:latin typeface="Calibri"/>
+                        </a:rPr>
+                        <a:t>675.7</a:t>
+                      </a:r>
+                    </a:p>
+                  </a:txBody>
+                  <a:tcPr marL="73152" marR="73152" marT="27432" marB="27432" anchor="ctr">
+                    <a:solidFill>
+                      <a:srgbClr val="FCFCFB"/>
+                    </a:solidFill>
+                  </a:tcPr>
+                </a:tc>
+              </a:tr>
+              <a:tr h="566928">
+                <a:tc>
+                  <a:txBody>
+                    <a:bodyPr wrap="square"/>
+                    <a:lstStyle/>
+                    <a:p>
+                      <a:pPr algn="l"/>
+                      <a:r>
+                        <a:rPr sz="1400" b="0">
+                          <a:solidFill>
+                            <a:srgbClr val="0B0B0B"/>
+                          </a:solidFill>
+                          <a:latin typeface="Calibri"/>
+                        </a:rPr>
+                        <a:t>Vulp i32 table</a:t>
+                      </a:r>
+                    </a:p>
+                  </a:txBody>
+                  <a:tcPr marL="73152" marR="73152" marT="27432" marB="27432" anchor="ctr">
+                    <a:solidFill>
+                      <a:srgbClr val="F6F5F2"/>
+                    </a:solidFill>
+                  </a:tcPr>
+                </a:tc>
+                <a:tc>
+                  <a:txBody>
+                    <a:bodyPr wrap="square"/>
+                    <a:lstStyle/>
+                    <a:p>
+                      <a:pPr algn="r"/>
+                      <a:r>
+                        <a:rPr sz="1400" b="0">
+                          <a:solidFill>
+                            <a:srgbClr val="0B0B0B"/>
+                          </a:solidFill>
+                          <a:latin typeface="Calibri"/>
+                        </a:rPr>
+                        <a:t>0.033</a:t>
+                      </a:r>
+                    </a:p>
+                  </a:txBody>
+                  <a:tcPr marL="73152" marR="73152" marT="27432" marB="27432" anchor="ctr">
+                    <a:solidFill>
+                      <a:srgbClr val="F6F5F2"/>
+                    </a:solidFill>
+                  </a:tcPr>
+                </a:tc>
+                <a:tc>
+                  <a:txBody>
+                    <a:bodyPr wrap="square"/>
+                    <a:lstStyle/>
+                    <a:p>
+                      <a:pPr algn="r"/>
+                      <a:r>
+                        <a:rPr sz="1400" b="0">
+                          <a:solidFill>
+                            <a:srgbClr val="0B0B0B"/>
+                          </a:solidFill>
+                          <a:latin typeface="Calibri"/>
+                        </a:rPr>
+                        <a:t>38.1</a:t>
+                      </a:r>
+                    </a:p>
+                  </a:txBody>
+                  <a:tcPr marL="73152" marR="73152" marT="27432" marB="27432" anchor="ctr">
+                    <a:solidFill>
+                      <a:srgbClr val="F6F5F2"/>
+                    </a:solidFill>
+                  </a:tcPr>
+                </a:tc>
+              </a:tr>
+              <a:tr h="566928">
+                <a:tc>
+                  <a:txBody>
+                    <a:bodyPr wrap="square"/>
+                    <a:lstStyle/>
+                    <a:p>
+                      <a:pPr algn="l"/>
+                      <a:r>
+                        <a:rPr sz="1400" b="0">
+                          <a:solidFill>
+                            <a:srgbClr val="0B0B0B"/>
+                          </a:solidFill>
+                          <a:latin typeface="Calibri"/>
+                        </a:rPr>
+                        <a:t>C++ bottom-up table</a:t>
+                      </a:r>
+                    </a:p>
+                  </a:txBody>
+                  <a:tcPr marL="73152" marR="73152" marT="27432" marB="27432" anchor="ctr">
+                    <a:solidFill>
+                      <a:srgbClr val="FCFCFB"/>
+                    </a:solidFill>
+                  </a:tcPr>
+                </a:tc>
+                <a:tc>
+                  <a:txBody>
+                    <a:bodyPr wrap="square"/>
+                    <a:lstStyle/>
+                    <a:p>
+                      <a:pPr algn="r"/>
+                      <a:r>
+                        <a:rPr sz="1400" b="0">
+                          <a:solidFill>
+                            <a:srgbClr val="0B0B0B"/>
+                          </a:solidFill>
+                          <a:latin typeface="Calibri"/>
+                        </a:rPr>
+                        <a:t>0.024</a:t>
+                      </a:r>
+                    </a:p>
+                  </a:txBody>
+                  <a:tcPr marL="73152" marR="73152" marT="27432" marB="27432" anchor="ctr">
+                    <a:solidFill>
+                      <a:srgbClr val="FCFCFB"/>
+                    </a:solidFill>
+                  </a:tcPr>
+                </a:tc>
+                <a:tc>
+                  <a:txBody>
+                    <a:bodyPr wrap="square"/>
+                    <a:lstStyle/>
+                    <a:p>
+                      <a:pPr algn="r"/>
+                      <a:r>
+                        <a:rPr sz="1400" b="0">
+                          <a:solidFill>
+                            <a:srgbClr val="0B0B0B"/>
+                          </a:solidFill>
+                          <a:latin typeface="Calibri"/>
+                        </a:rPr>
+                        <a:t>37.5</a:t>
+                      </a:r>
+                    </a:p>
+                  </a:txBody>
+                  <a:tcPr marL="73152" marR="73152" marT="27432" marB="27432" anchor="ctr">
+                    <a:solidFill>
+                      <a:srgbClr val="FCFCFB"/>
+                    </a:solidFill>
+                  </a:tcPr>
+                </a:tc>
+              </a:tr>
+              <a:tr h="566928">
+                <a:tc>
+                  <a:txBody>
+                    <a:bodyPr wrap="square"/>
+                    <a:lstStyle/>
+                    <a:p>
+                      <a:pPr algn="l"/>
+                      <a:r>
+                        <a:rPr sz="1400" b="0">
+                          <a:solidFill>
+                            <a:srgbClr val="0B0B0B"/>
+                          </a:solidFill>
+                          <a:latin typeface="Calibri"/>
+                        </a:rPr>
+                        <a:t>C++ recursion with unordered_map</a:t>
+                      </a:r>
+                    </a:p>
+                  </a:txBody>
+                  <a:tcPr marL="73152" marR="73152" marT="27432" marB="27432" anchor="ctr">
+                    <a:solidFill>
+                      <a:srgbClr val="F6F5F2"/>
+                    </a:solidFill>
+                  </a:tcPr>
+                </a:tc>
+                <a:tc>
+                  <a:txBody>
+                    <a:bodyPr wrap="square"/>
+                    <a:lstStyle/>
+                    <a:p>
+                      <a:pPr algn="r"/>
+                      <a:r>
+                        <a:rPr sz="1400" b="0">
+                          <a:solidFill>
+                            <a:srgbClr val="0B0B0B"/>
+                          </a:solidFill>
+                          <a:latin typeface="Calibri"/>
+                        </a:rPr>
+                        <a:t>0.579</a:t>
+                      </a:r>
+                    </a:p>
+                  </a:txBody>
+                  <a:tcPr marL="73152" marR="73152" marT="27432" marB="27432" anchor="ctr">
+                    <a:solidFill>
+                      <a:srgbClr val="F6F5F2"/>
+                    </a:solidFill>
+                  </a:tcPr>
+                </a:tc>
+                <a:tc>
+                  <a:txBody>
+                    <a:bodyPr wrap="square"/>
+                    <a:lstStyle/>
+                    <a:p>
+                      <a:pPr algn="r"/>
+                      <a:r>
+                        <a:rPr sz="1400" b="0">
+                          <a:solidFill>
+                            <a:srgbClr val="0B0B0B"/>
+                          </a:solidFill>
+                          <a:latin typeface="Calibri"/>
+                        </a:rPr>
+                        <a:t>323.4</a:t>
+                      </a:r>
+                    </a:p>
+                  </a:txBody>
+                  <a:tcPr marL="73152" marR="73152" marT="27432" marB="27432" anchor="ctr">
+                    <a:solidFill>
+                      <a:srgbClr val="F6F5F2"/>
+                    </a:solidFill>
+                  </a:tcPr>
+                </a:tc>
+              </a:tr>
+            </a:tbl>
+          </a:graphicData>
+        </a:graphic>
+      </p:graphicFrame>
       <p:sp>
         <p:nvSpPr>
           <p:cNvPr id="5" name="TextBox 4"/>
@@ -6756,8 +7114,8 @@
         </p:nvSpPr>
         <p:spPr>
           <a:xfrm>
-            <a:off x="8229600" y="1463040"/>
-            <a:ext cx="3474720" cy="4754880"/>
+            <a:off x="8138160" y="1508760"/>
+            <a:ext cx="3474720" cy="4663440"/>
           </a:xfrm>
           <a:prstGeom prst="rect">
             <a:avLst/>
@@ -6785,7 +7143,7 @@
                 </a:solidFill>
                 <a:latin typeface="Calibri"/>
               </a:rPr>
-              <a:t>•  On 9·10⁶ states, dp fn is 2.8× slower and 2.1× larger than hand-memoised C++</a:t>
+              <a:t>•  LCS fills a dense 3000 by 3000 table</a:t>
             </a:r>
           </a:p>
           <a:p>
@@ -6804,7 +7162,7 @@
                 </a:solidFill>
                 <a:latin typeface="Calibri"/>
               </a:rPr>
-              <a:t>•  Causes: byte-wise hashing, two probes per miss, 28-byte entries, rehash on growth</a:t>
+              <a:t>•  Vulp dp fn takes 1.581 s and uses 675.7 MiB</a:t>
             </a:r>
           </a:p>
           <a:p>
@@ -6823,7 +7181,7 @@
                 </a:solidFill>
                 <a:latin typeface="Calibri"/>
               </a:rPr>
-              <a:t>•  Typical contest sizes (≤ 10⁶ states) still finish well under a second</a:t>
+              <a:t>•  The Vulp i32 table is 48x faster and uses 18x less memory</a:t>
             </a:r>
           </a:p>
           <a:p>
@@ -6842,7 +7200,7 @@
                 </a:solidFill>
                 <a:latin typeface="Calibri"/>
               </a:rPr>
-              <a:t>•  A table is always faster: dp fn buys brevity and safety</a:t>
+              <a:t>•  dp fn is useful when recursion revisits states; a dense table suits this workload</a:t>
             </a:r>
           </a:p>
         </p:txBody>
@@ -7188,7 +7546,7 @@
                           </a:solidFill>
                           <a:latin typeface="Calibri"/>
                         </a:rPr>
-                        <a:t>0.057 s</a:t>
+                        <a:t>0.041 s</a:t>
                       </a:r>
                     </a:p>
                   </a:txBody>
@@ -7211,7 +7569,7 @@
                           </a:solidFill>
                           <a:latin typeface="Calibri"/>
                         </a:rPr>
-                        <a:t>0.059 s</a:t>
+                        <a:t>0.041 s</a:t>
                       </a:r>
                     </a:p>
                   </a:txBody>
@@ -7234,7 +7592,7 @@
                           </a:solidFill>
                           <a:latin typeface="Calibri"/>
                         </a:rPr>
-                        <a:t>-3%</a:t>
+                        <a:t>-1%</a:t>
                       </a:r>
                     </a:p>
                   </a:txBody>
@@ -7282,7 +7640,7 @@
                           </a:solidFill>
                           <a:latin typeface="Calibri"/>
                         </a:rPr>
-                        <a:t>0.138 s</a:t>
+                        <a:t>0.100 s</a:t>
                       </a:r>
                     </a:p>
                   </a:txBody>
@@ -7305,7 +7663,7 @@
                           </a:solidFill>
                           <a:latin typeface="Calibri"/>
                         </a:rPr>
-                        <a:t>0.138 s</a:t>
+                        <a:t>0.099 s</a:t>
                       </a:r>
                     </a:p>
                   </a:txBody>
@@ -7328,7 +7686,7 @@
                           </a:solidFill>
                           <a:latin typeface="Calibri"/>
                         </a:rPr>
-                        <a:t>+1%</a:t>
+                        <a:t>+0%</a:t>
                       </a:r>
                     </a:p>
                   </a:txBody>
@@ -7376,7 +7734,7 @@
                           </a:solidFill>
                           <a:latin typeface="Calibri"/>
                         </a:rPr>
-                        <a:t>2.071 s</a:t>
+                        <a:t>1.555 s</a:t>
                       </a:r>
                     </a:p>
                   </a:txBody>
@@ -7399,7 +7757,7 @@
                           </a:solidFill>
                           <a:latin typeface="Calibri"/>
                         </a:rPr>
-                        <a:t>2.062 s</a:t>
+                        <a:t>1.551 s</a:t>
                       </a:r>
                     </a:p>
                   </a:txBody>
@@ -7470,7 +7828,7 @@
                           </a:solidFill>
                           <a:latin typeface="Calibri"/>
                         </a:rPr>
-                        <a:t>0.060 s</a:t>
+                        <a:t>0.048 s</a:t>
                       </a:r>
                     </a:p>
                   </a:txBody>
@@ -7493,7 +7851,7 @@
                           </a:solidFill>
                           <a:latin typeface="Calibri"/>
                         </a:rPr>
-                        <a:t>0.054 s</a:t>
+                        <a:t>0.043 s</a:t>
                       </a:r>
                     </a:p>
                   </a:txBody>
@@ -7516,7 +7874,7 @@
                           </a:solidFill>
                           <a:latin typeface="Calibri"/>
                         </a:rPr>
-                        <a:t>+10%</a:t>
+                        <a:t>+11%</a:t>
                       </a:r>
                     </a:p>
                   </a:txBody>
@@ -7564,7 +7922,7 @@
                           </a:solidFill>
                           <a:latin typeface="Calibri"/>
                         </a:rPr>
-                        <a:t>0.124 s</a:t>
+                        <a:t>0.080 s</a:t>
                       </a:r>
                     </a:p>
                   </a:txBody>
@@ -7587,7 +7945,7 @@
                           </a:solidFill>
                           <a:latin typeface="Calibri"/>
                         </a:rPr>
-                        <a:t>0.122 s</a:t>
+                        <a:t>0.080 s</a:t>
                       </a:r>
                     </a:p>
                   </a:txBody>
@@ -7610,7 +7968,7 @@
                           </a:solidFill>
                           <a:latin typeface="Calibri"/>
                         </a:rPr>
-                        <a:t>+2%</a:t>
+                        <a:t>+1%</a:t>
                       </a:r>
                     </a:p>
                   </a:txBody>
@@ -7658,7 +8016,7 @@
                           </a:solidFill>
                           <a:latin typeface="Calibri"/>
                         </a:rPr>
-                        <a:t>0.072 s</a:t>
+                        <a:t>0.054 s</a:t>
                       </a:r>
                     </a:p>
                   </a:txBody>
@@ -7681,7 +8039,7 @@
                           </a:solidFill>
                           <a:latin typeface="Calibri"/>
                         </a:rPr>
-                        <a:t>0.071 s</a:t>
+                        <a:t>0.054 s</a:t>
                       </a:r>
                     </a:p>
                   </a:txBody>
@@ -7752,7 +8110,7 @@
                           </a:solidFill>
                           <a:latin typeface="Calibri"/>
                         </a:rPr>
-                        <a:t>0.537 s</a:t>
+                        <a:t>0.283 s</a:t>
                       </a:r>
                     </a:p>
                   </a:txBody>
@@ -7775,7 +8133,7 @@
                           </a:solidFill>
                           <a:latin typeface="Calibri"/>
                         </a:rPr>
-                        <a:t>0.552 s</a:t>
+                        <a:t>0.278 s</a:t>
                       </a:r>
                     </a:p>
                   </a:txBody>
@@ -7798,7 +8156,7 @@
                           </a:solidFill>
                           <a:latin typeface="Calibri"/>
                         </a:rPr>
-                        <a:t>-3%</a:t>
+                        <a:t>+2%</a:t>
                       </a:r>
                     </a:p>
                   </a:txBody>
@@ -7986,7 +8344,7 @@
                           </a:solidFill>
                           <a:latin typeface="Calibri"/>
                         </a:rPr>
-                        <a:t>0.061 s</a:t>
+                        <a:t>0.048 s</a:t>
                       </a:r>
                     </a:p>
                   </a:txBody>
@@ -8009,7 +8367,7 @@
                           </a:solidFill>
                           <a:latin typeface="Calibri"/>
                         </a:rPr>
-                        <a:t>72 MiB</a:t>
+                        <a:t>73 MiB</a:t>
                       </a:r>
                     </a:p>
                   </a:txBody>
@@ -8057,7 +8415,7 @@
                           </a:solidFill>
                           <a:latin typeface="Calibri"/>
                         </a:rPr>
-                        <a:t>0.055 s</a:t>
+                        <a:t>0.043 s</a:t>
                       </a:r>
                     </a:p>
                   </a:txBody>
@@ -8080,7 +8438,7 @@
                           </a:solidFill>
                           <a:latin typeface="Calibri"/>
                         </a:rPr>
-                        <a:t>72 MiB</a:t>
+                        <a:t>73 MiB</a:t>
                       </a:r>
                     </a:p>
                   </a:txBody>
@@ -8128,7 +8486,7 @@
                           </a:solidFill>
                           <a:latin typeface="Calibri"/>
                         </a:rPr>
-                        <a:t>0.043 s</a:t>
+                        <a:t>0.032 s</a:t>
                       </a:r>
                     </a:p>
                   </a:txBody>
@@ -8199,7 +8557,7 @@
                           </a:solidFill>
                           <a:latin typeface="Calibri"/>
                         </a:rPr>
-                        <a:t>0.036 s</a:t>
+                        <a:t>0.027 s</a:t>
                       </a:r>
                     </a:p>
                   </a:txBody>
@@ -8274,7 +8632,7 @@
                 </a:solidFill>
                 <a:latin typeface="Calibri"/>
               </a:rPr>
-              <a:t>•  Checks cost ≤ 10%, only in the innermost loop of a dense DP</a:t>
+              <a:t>•  Checks cost 11% on dense LCS and 0-2% elsewhere</a:t>
             </a:r>
           </a:p>
           <a:p>
@@ -8293,7 +8651,7 @@
                 </a:solidFill>
                 <a:latin typeface="Calibri"/>
               </a:rPr>
-              <a:t>•  One word, int → i32, halves memory and gives 1.4×</a:t>
+              <a:t>•  In the width experiment, i32 uses about half the memory and is 1.5x faster than int</a:t>
             </a:r>
           </a:p>
         </p:txBody>
@@ -9930,7 +10288,7 @@
                 </a:solidFill>
                 <a:latin typeface="Calibri"/>
               </a:rPr>
-              <a:t>•  Memo table specialised by key size, one probe per miss: target parity with C++ (now 2.8×)</a:t>
+              <a:t>•  Memo table specialised by key size, one probe per miss: target parity with C++ (2.7x slower on LCS)</a:t>
             </a:r>
           </a:p>
           <a:p>
@@ -9949,7 +10307,7 @@
                 </a:solidFill>
                 <a:latin typeface="Calibri"/>
               </a:rPr>
-              <a:t>•  Map values stored inline, for k, v in m: close the 1.46× gap</a:t>
+              <a:t>•  Map values stored inline, for k, v in m: reduce the 1.42x gap</a:t>
             </a:r>
           </a:p>
           <a:p>
@@ -9968,7 +10326,7 @@
                 </a:solidFill>
                 <a:latin typeface="Calibri"/>
               </a:rPr>
-              <a:t>•  Suggest i32 when DP values provably fit (1.4×)</a:t>
+              <a:t>•  Suggest i32 when DP values provably fit (about half the memory in LCS)</a:t>
             </a:r>
           </a:p>
         </p:txBody>
@@ -12872,7 +13230,7 @@
                 </a:solidFill>
                 <a:latin typeface="Calibri"/>
               </a:rPr>
-              <a:t>200,000 testcases:   Vulp 0.071 s   ·   C++ 0.073 s   ·   Python 0.383 s</a:t>
+              <a:t>200,000 testcases:   Vulp 0.055 s   ·   C++ 0.055 s   ·   Python 0.305 s</a:t>
             </a:r>
           </a:p>
         </p:txBody>
@@ -13180,7 +13538,26 @@
                 </a:solidFill>
                 <a:latin typeface="Consolas"/>
               </a:rPr>
-              <a:t>println(fib(42));</a:t>
+              <a:t>read int n;</a:t>
+            </a:r>
+          </a:p>
+          <a:p>
+            <a:pPr algn="l">
+              <a:lnSpc>
+                <a:spcPct val="100000"/>
+              </a:lnSpc>
+              <a:spcAft>
+                <a:spcPts val="0"/>
+              </a:spcAft>
+            </a:pPr>
+            <a:r>
+              <a:rPr sz="1500" b="0">
+                <a:solidFill>
+                  <a:srgbClr val="0B0B0B"/>
+                </a:solidFill>
+                <a:latin typeface="Consolas"/>
+              </a:rPr>
+              <a:t>println(fib(n));</a:t>
             </a:r>
           </a:p>
         </p:txBody>
@@ -13314,7 +13691,7 @@
                 </a:solidFill>
                 <a:latin typeface="Calibri"/>
               </a:rPr>
-              <a:t>0.92 s</a:t>
+              <a:t>0.198 s</a:t>
             </a:r>
           </a:p>
         </p:txBody>
@@ -13356,7 +13733,7 @@
                 </a:solidFill>
                 <a:latin typeface="Calibri"/>
               </a:rPr>
-              <a:t>fn fib(42): 867 million calls</a:t>
+              <a:t>Vulp plain fib(40)</a:t>
             </a:r>
           </a:p>
         </p:txBody>
@@ -13490,7 +13867,7 @@
                 </a:solidFill>
                 <a:latin typeface="Calibri"/>
               </a:rPr>
-              <a:t>&lt; 0.01 s</a:t>
+              <a:t>1.57 ms</a:t>
             </a:r>
           </a:p>
         </p:txBody>
@@ -13532,7 +13909,7 @@
                 </a:solidFill>
                 <a:latin typeface="Calibri"/>
               </a:rPr>
-              <a:t>dp fn fib(42): 43 states</a:t>
+              <a:t>Vulp dp fn fib(40), 41 states</a:t>
             </a:r>
           </a:p>
         </p:txBody>
@@ -13574,7 +13951,7 @@
                 </a:solidFill>
                 <a:latin typeface="Calibri"/>
               </a:rPr>
-              <a:t>The only difference is the keyword dp.</a:t>
+              <a:t>Plain C++: 0.107 s; plain Python: 8.26 s.</a:t>
             </a:r>
           </a:p>
         </p:txBody>
@@ -13696,7 +14073,7 @@
                 </a:solidFill>
                 <a:latin typeface="Calibri"/>
               </a:rPr>
-              <a:t>•  No global writes, no I/O — also through callees</a:t>
+              <a:t>•  No global writes or I/O, including through callees</a:t>
             </a:r>
           </a:p>
           <a:p>
@@ -14420,7 +14797,7 @@
                 </a:solidFill>
                 <a:latin typeface="Calibri"/>
               </a:rPr>
-              <a:t>Bounds, division by zero, empty pop, end of input, input overflow. Cost: ≤ 10%; --no-checks removes them.</a:t>
+              <a:t>Bounds, division by zero, empty pop, end of input, input overflow. Cost: 11% on dense LCS, 0-2% elsewhere.</a:t>
             </a:r>
           </a:p>
         </p:txBody>

</xml_diff>